<commit_message>
Added Q teams, and also updated the leaderboad system with updated backend
</commit_message>
<xml_diff>
--- a/public/PPT sankalp.pptx
+++ b/public/PPT sankalp.pptx
@@ -13,30 +13,29 @@
     <p:sldId id="261" r:id="rId11"/>
     <p:sldId id="262" r:id="rId12"/>
     <p:sldId id="263" r:id="rId13"/>
-    <p:sldId id="264" r:id="rId14"/>
   </p:sldIdLst>
   <p:sldSz cx="18288000" cy="10287000"/>
   <p:notesSz cx="6858000" cy="9144000"/>
   <p:embeddedFontLst>
     <p:embeddedFont>
       <p:font typeface="Gotham Bold" charset="1" panose="00000000000000000000"/>
+      <p:regular r:id="rId14"/>
+    </p:embeddedFont>
+    <p:embeddedFont>
+      <p:font typeface="Lastica" charset="1" panose="02000500000000000000"/>
       <p:regular r:id="rId15"/>
     </p:embeddedFont>
     <p:embeddedFont>
-      <p:font typeface="Lastica" charset="1" panose="02000500000000000000"/>
+      <p:font typeface="Poppins Bold" charset="1" panose="00000800000000000000"/>
       <p:regular r:id="rId16"/>
     </p:embeddedFont>
     <p:embeddedFont>
-      <p:font typeface="Poppins Bold" charset="1" panose="00000800000000000000"/>
+      <p:font typeface="Intro Rust" charset="1" panose="00000500000000000000"/>
       <p:regular r:id="rId17"/>
     </p:embeddedFont>
     <p:embeddedFont>
-      <p:font typeface="Intro Rust" charset="1" panose="00000500000000000000"/>
+      <p:font typeface="Poppins" charset="1" panose="00000500000000000000"/>
       <p:regular r:id="rId18"/>
-    </p:embeddedFont>
-    <p:embeddedFont>
-      <p:font typeface="Poppins" charset="1" panose="00000500000000000000"/>
-      <p:regular r:id="rId19"/>
     </p:embeddedFont>
   </p:embeddedFontLst>
   <p:defaultTextStyle>
@@ -8077,363 +8076,6 @@
 </p:sld>
 </file>
 
-<file path=ppt/slides/slide9.xml><?xml version="1.0" encoding="utf-8"?>
-<p:sld xmlns:p="http://schemas.openxmlformats.org/presentationml/2006/main" xmlns:a="http://schemas.openxmlformats.org/drawingml/2006/main" xmlns:r="http://schemas.openxmlformats.org/officeDocument/2006/relationships">
-  <p:cSld>
-    <p:spTree>
-      <p:nvGrpSpPr>
-        <p:cNvPr id="1" name=""/>
-        <p:cNvGrpSpPr/>
-        <p:nvPr/>
-      </p:nvGrpSpPr>
-      <p:grpSpPr>
-        <a:xfrm>
-          <a:off x="0" y="0"/>
-          <a:ext cx="0" cy="0"/>
-          <a:chOff x="0" y="0"/>
-          <a:chExt cx="0" cy="0"/>
-        </a:xfrm>
-      </p:grpSpPr>
-      <p:grpSp>
-        <p:nvGrpSpPr>
-          <p:cNvPr name="Group 2" id="2"/>
-          <p:cNvGrpSpPr/>
-          <p:nvPr/>
-        </p:nvGrpSpPr>
-        <p:grpSpPr>
-          <a:xfrm rot="0">
-            <a:off x="514757" y="1250053"/>
-            <a:ext cx="17632563" cy="2108721"/>
-            <a:chOff x="0" y="0"/>
-            <a:chExt cx="23510084" cy="2811628"/>
-          </a:xfrm>
-        </p:grpSpPr>
-        <p:sp>
-          <p:nvSpPr>
-            <p:cNvPr name="Freeform 3" id="3"/>
-            <p:cNvSpPr/>
-            <p:nvPr/>
-          </p:nvSpPr>
-          <p:spPr>
-            <a:xfrm flipH="false" flipV="false" rot="0">
-              <a:off x="0" y="0"/>
-              <a:ext cx="23510084" cy="2811628"/>
-            </a:xfrm>
-            <a:custGeom>
-              <a:avLst/>
-              <a:gdLst/>
-              <a:ahLst/>
-              <a:cxnLst/>
-              <a:rect r="r" b="b" t="t" l="l"/>
-              <a:pathLst>
-                <a:path h="2811628" w="23510084">
-                  <a:moveTo>
-                    <a:pt x="0" y="0"/>
-                  </a:moveTo>
-                  <a:lnTo>
-                    <a:pt x="23510084" y="0"/>
-                  </a:lnTo>
-                  <a:lnTo>
-                    <a:pt x="23510084" y="2811628"/>
-                  </a:lnTo>
-                  <a:lnTo>
-                    <a:pt x="0" y="2811628"/>
-                  </a:lnTo>
-                  <a:lnTo>
-                    <a:pt x="0" y="0"/>
-                  </a:lnTo>
-                  <a:close/>
-                </a:path>
-              </a:pathLst>
-            </a:custGeom>
-            <a:blipFill>
-              <a:blip r:embed="rId2"/>
-              <a:stretch>
-                <a:fillRect l="0" t="-224546" r="-6376" b="-479332"/>
-              </a:stretch>
-            </a:blipFill>
-          </p:spPr>
-        </p:sp>
-        <p:sp>
-          <p:nvSpPr>
-            <p:cNvPr name="Freeform 4" id="4"/>
-            <p:cNvSpPr/>
-            <p:nvPr/>
-          </p:nvSpPr>
-          <p:spPr>
-            <a:xfrm flipH="false" flipV="false" rot="0">
-              <a:off x="6422315" y="292223"/>
-              <a:ext cx="11382637" cy="1537309"/>
-            </a:xfrm>
-            <a:custGeom>
-              <a:avLst/>
-              <a:gdLst/>
-              <a:ahLst/>
-              <a:cxnLst/>
-              <a:rect r="r" b="b" t="t" l="l"/>
-              <a:pathLst>
-                <a:path h="1537309" w="11382637">
-                  <a:moveTo>
-                    <a:pt x="0" y="0"/>
-                  </a:moveTo>
-                  <a:lnTo>
-                    <a:pt x="11382637" y="0"/>
-                  </a:lnTo>
-                  <a:lnTo>
-                    <a:pt x="11382637" y="1537309"/>
-                  </a:lnTo>
-                  <a:lnTo>
-                    <a:pt x="0" y="1537309"/>
-                  </a:lnTo>
-                  <a:lnTo>
-                    <a:pt x="0" y="0"/>
-                  </a:lnTo>
-                  <a:close/>
-                </a:path>
-              </a:pathLst>
-            </a:custGeom>
-            <a:blipFill>
-              <a:blip r:embed="rId3"/>
-              <a:stretch>
-                <a:fillRect l="-16858" t="-15040" r="-2110" b="-34707"/>
-              </a:stretch>
-            </a:blipFill>
-          </p:spPr>
-        </p:sp>
-        <p:sp>
-          <p:nvSpPr>
-            <p:cNvPr name="Freeform 5" id="5"/>
-            <p:cNvSpPr/>
-            <p:nvPr/>
-          </p:nvSpPr>
-          <p:spPr>
-            <a:xfrm flipH="false" flipV="false" rot="0">
-              <a:off x="6850086" y="1829532"/>
-              <a:ext cx="10403127" cy="307682"/>
-            </a:xfrm>
-            <a:custGeom>
-              <a:avLst/>
-              <a:gdLst/>
-              <a:ahLst/>
-              <a:cxnLst/>
-              <a:rect r="r" b="b" t="t" l="l"/>
-              <a:pathLst>
-                <a:path h="307682" w="10403127">
-                  <a:moveTo>
-                    <a:pt x="0" y="0"/>
-                  </a:moveTo>
-                  <a:lnTo>
-                    <a:pt x="10403127" y="0"/>
-                  </a:lnTo>
-                  <a:lnTo>
-                    <a:pt x="10403127" y="307682"/>
-                  </a:lnTo>
-                  <a:lnTo>
-                    <a:pt x="0" y="307682"/>
-                  </a:lnTo>
-                  <a:lnTo>
-                    <a:pt x="0" y="0"/>
-                  </a:lnTo>
-                  <a:close/>
-                </a:path>
-              </a:pathLst>
-            </a:custGeom>
-            <a:blipFill>
-              <a:blip r:embed="rId4"/>
-              <a:stretch>
-                <a:fillRect l="0" t="-452658" r="0" b="-22134"/>
-              </a:stretch>
-            </a:blipFill>
-          </p:spPr>
-        </p:sp>
-        <p:sp>
-          <p:nvSpPr>
-            <p:cNvPr name="Freeform 6" id="6"/>
-            <p:cNvSpPr/>
-            <p:nvPr/>
-          </p:nvSpPr>
-          <p:spPr>
-            <a:xfrm flipH="false" flipV="false" rot="0">
-              <a:off x="4950031" y="452286"/>
-              <a:ext cx="1462566" cy="1462566"/>
-            </a:xfrm>
-            <a:custGeom>
-              <a:avLst/>
-              <a:gdLst/>
-              <a:ahLst/>
-              <a:cxnLst/>
-              <a:rect r="r" b="b" t="t" l="l"/>
-              <a:pathLst>
-                <a:path h="1462566" w="1462566">
-                  <a:moveTo>
-                    <a:pt x="0" y="0"/>
-                  </a:moveTo>
-                  <a:lnTo>
-                    <a:pt x="1462567" y="0"/>
-                  </a:lnTo>
-                  <a:lnTo>
-                    <a:pt x="1462567" y="1462566"/>
-                  </a:lnTo>
-                  <a:lnTo>
-                    <a:pt x="0" y="1462566"/>
-                  </a:lnTo>
-                  <a:lnTo>
-                    <a:pt x="0" y="0"/>
-                  </a:lnTo>
-                  <a:close/>
-                </a:path>
-              </a:pathLst>
-            </a:custGeom>
-            <a:blipFill>
-              <a:blip r:embed="rId5"/>
-              <a:stretch>
-                <a:fillRect l="0" t="0" r="0" b="0"/>
-              </a:stretch>
-            </a:blipFill>
-          </p:spPr>
-        </p:sp>
-        <p:sp>
-          <p:nvSpPr>
-            <p:cNvPr name="Freeform 7" id="7"/>
-            <p:cNvSpPr/>
-            <p:nvPr/>
-          </p:nvSpPr>
-          <p:spPr>
-            <a:xfrm flipH="false" flipV="false" rot="0">
-              <a:off x="1843084" y="596677"/>
-              <a:ext cx="1540537" cy="1540537"/>
-            </a:xfrm>
-            <a:custGeom>
-              <a:avLst/>
-              <a:gdLst/>
-              <a:ahLst/>
-              <a:cxnLst/>
-              <a:rect r="r" b="b" t="t" l="l"/>
-              <a:pathLst>
-                <a:path h="1540537" w="1540537">
-                  <a:moveTo>
-                    <a:pt x="0" y="0"/>
-                  </a:moveTo>
-                  <a:lnTo>
-                    <a:pt x="1540538" y="0"/>
-                  </a:lnTo>
-                  <a:lnTo>
-                    <a:pt x="1540538" y="1540537"/>
-                  </a:lnTo>
-                  <a:lnTo>
-                    <a:pt x="0" y="1540537"/>
-                  </a:lnTo>
-                  <a:lnTo>
-                    <a:pt x="0" y="0"/>
-                  </a:lnTo>
-                  <a:close/>
-                </a:path>
-              </a:pathLst>
-            </a:custGeom>
-            <a:blipFill>
-              <a:blip r:embed="rId6"/>
-              <a:stretch>
-                <a:fillRect l="-2310" t="-28500" r="0" b="-27400"/>
-              </a:stretch>
-            </a:blipFill>
-          </p:spPr>
-        </p:sp>
-        <p:sp>
-          <p:nvSpPr>
-            <p:cNvPr name="Freeform 8" id="8"/>
-            <p:cNvSpPr/>
-            <p:nvPr/>
-          </p:nvSpPr>
-          <p:spPr>
-            <a:xfrm flipH="false" flipV="false" rot="0">
-              <a:off x="18904179" y="429892"/>
-              <a:ext cx="2762820" cy="1781175"/>
-            </a:xfrm>
-            <a:custGeom>
-              <a:avLst/>
-              <a:gdLst/>
-              <a:ahLst/>
-              <a:cxnLst/>
-              <a:rect r="r" b="b" t="t" l="l"/>
-              <a:pathLst>
-                <a:path h="1781175" w="2762820">
-                  <a:moveTo>
-                    <a:pt x="0" y="0"/>
-                  </a:moveTo>
-                  <a:lnTo>
-                    <a:pt x="2762820" y="0"/>
-                  </a:lnTo>
-                  <a:lnTo>
-                    <a:pt x="2762820" y="1781175"/>
-                  </a:lnTo>
-                  <a:lnTo>
-                    <a:pt x="0" y="1781175"/>
-                  </a:lnTo>
-                  <a:lnTo>
-                    <a:pt x="0" y="0"/>
-                  </a:lnTo>
-                  <a:close/>
-                </a:path>
-              </a:pathLst>
-            </a:custGeom>
-            <a:blipFill>
-              <a:blip r:embed="rId7"/>
-              <a:stretch>
-                <a:fillRect l="0" t="0" r="0" b="0"/>
-              </a:stretch>
-            </a:blipFill>
-          </p:spPr>
-        </p:sp>
-        <p:sp>
-          <p:nvSpPr>
-            <p:cNvPr name="TextBox 9" id="9"/>
-            <p:cNvSpPr txBox="true"/>
-            <p:nvPr/>
-          </p:nvSpPr>
-          <p:spPr>
-            <a:xfrm rot="0">
-              <a:off x="3502261" y="2096044"/>
-              <a:ext cx="15750461" cy="445887"/>
-            </a:xfrm>
-            <a:prstGeom prst="rect">
-              <a:avLst/>
-            </a:prstGeom>
-          </p:spPr>
-          <p:txBody>
-            <a:bodyPr anchor="t" rtlCol="false" tIns="0" lIns="0" bIns="0" rIns="0">
-              <a:spAutoFit/>
-            </a:bodyPr>
-            <a:lstStyle/>
-            <a:p>
-              <a:pPr algn="ctr">
-                <a:lnSpc>
-                  <a:spcPts val="2698"/>
-                </a:lnSpc>
-              </a:pPr>
-              <a:r>
-                <a:rPr lang="en-US" sz="1927" spc="59">
-                  <a:solidFill>
-                    <a:srgbClr val="EEF8FD"/>
-                  </a:solidFill>
-                  <a:latin typeface="Lastica"/>
-                  <a:ea typeface="Lastica"/>
-                  <a:cs typeface="Lastica"/>
-                  <a:sym typeface="Lastica"/>
-                </a:rPr>
-                <a:t>DEPARTMENT OF COMPUTER SCIENCE AND ENGINEERING &amp; III CELL</a:t>
-              </a:r>
-            </a:p>
-          </p:txBody>
-        </p:sp>
-      </p:grpSp>
-    </p:spTree>
-  </p:cSld>
-  <p:clrMapOvr>
-    <a:masterClrMapping/>
-  </p:clrMapOvr>
-</p:sld>
-</file>
-
 <file path=ppt/theme/theme1.xml><?xml version="1.0" encoding="utf-8"?>
 <a:theme xmlns:a="http://schemas.openxmlformats.org/drawingml/2006/main" name="Office Theme">
   <a:themeElements>

</xml_diff>